<commit_message>
Sync working tree: full MONARCH-CODEBASE VI copy, docs, cleanup list, team updates
- original-labview-codebase/MONARCH-CODEBASE/: curated copy of the LabVIEW
  source tree (binary .vis, .lvproj, libs, FPGA bitfiles, controls, support)
- Items-W-No-Callers/: per-target no-callers listings for the cleanup pass
- MONARCH-cleanup-list.xlsx: deletable-items list from the lvproj cross-ref
- screenshots/: project-explorer and dependency-view captures
- team-update/: progress/next-steps decks + their build scripts
- system docs (SCADA HMI, GUI reports, FPGA/overview PDFs), hello-vi.pdf
- refresh gateway VI GIF exports and monarch.jsonl recording snapshot

Co-Authored-By: Claude Fable 5 <noreply@anthropic.com>
</commit_message>
<xml_diff>
--- a/team-update/hello-vi-update.pptx
+++ b/team-update/hello-vi-update.pptx
@@ -5,9 +5,9 @@
     <p:sldMasterId id="2147483648" r:id="rId1"/>
   </p:sldMasterIdLst>
   <p:sldIdLst>
-    <p:sldId id="256" r:id="rId7"/>
+    <p:sldId id="256" r:id="rId2"/>
   </p:sldIdLst>
-  <p:sldSz cx="12191695" cy="6858000" type="screen4x3"/>
+  <p:sldSz cx="12192000" cy="6858000"/>
   <p:notesSz cx="6858000" cy="9144000"/>
   <p:defaultTextStyle>
     <a:defPPr>
@@ -104,6 +104,22 @@
       </a:defRPr>
     </a:lvl9pPr>
   </p:defaultTextStyle>
+  <p:extLst>
+    <p:ext uri="{EFAFB233-063F-42B5-8137-9DF3F51BA10A}">
+      <p15:sldGuideLst xmlns:p15="http://schemas.microsoft.com/office/powerpoint/2012/main">
+        <p15:guide id="1" orient="horz" pos="2160">
+          <p15:clr>
+            <a:srgbClr val="A4A3A4"/>
+          </p15:clr>
+        </p15:guide>
+        <p15:guide id="2" pos="2880">
+          <p15:clr>
+            <a:srgbClr val="A4A3A4"/>
+          </p15:clr>
+        </p15:guide>
+      </p15:sldGuideLst>
+    </p:ext>
+  </p:extLst>
 </p:presentation>
 </file>
 
@@ -145,10 +161,9 @@
           <a:lstStyle/>
           <a:p>
             <a:r>
-              <a:rPr lang="en-US" smtClean="0"/>
+              <a:rPr lang="en-US"/>
               <a:t>Click to edit Master title style</a:t>
             </a:r>
-            <a:endParaRPr lang="en-US"/>
           </a:p>
         </p:txBody>
       </p:sp>
@@ -264,10 +279,9 @@
           </a:lstStyle>
           <a:p>
             <a:r>
-              <a:rPr lang="en-US" smtClean="0"/>
+              <a:rPr lang="en-US"/>
               <a:t>Click to edit Master subtitle style</a:t>
             </a:r>
-            <a:endParaRPr lang="en-US"/>
           </a:p>
         </p:txBody>
       </p:sp>
@@ -288,7 +302,7 @@
           <a:p>
             <a:fld id="{5BCAD085-E8A6-8845-BD4E-CB4CCA059FC4}" type="datetimeFigureOut">
               <a:rPr lang="en-US" smtClean="0"/>
-              <a:t>1/27/13</a:t>
+              <a:t>7/2/2026</a:t>
             </a:fld>
             <a:endParaRPr lang="en-US"/>
           </a:p>
@@ -382,10 +396,9 @@
           <a:lstStyle/>
           <a:p>
             <a:r>
-              <a:rPr lang="en-US" smtClean="0"/>
+              <a:rPr lang="en-US"/>
               <a:t>Click to edit Master title style</a:t>
             </a:r>
-            <a:endParaRPr lang="en-US"/>
           </a:p>
         </p:txBody>
       </p:sp>
@@ -406,38 +419,37 @@
           <a:p>
             <a:pPr lvl="0"/>
             <a:r>
-              <a:rPr lang="en-US" smtClean="0"/>
+              <a:rPr lang="en-US"/>
               <a:t>Click to edit Master text styles</a:t>
             </a:r>
           </a:p>
           <a:p>
             <a:pPr lvl="1"/>
             <a:r>
-              <a:rPr lang="en-US" smtClean="0"/>
+              <a:rPr lang="en-US"/>
               <a:t>Second level</a:t>
             </a:r>
           </a:p>
           <a:p>
             <a:pPr lvl="2"/>
             <a:r>
-              <a:rPr lang="en-US" smtClean="0"/>
+              <a:rPr lang="en-US"/>
               <a:t>Third level</a:t>
             </a:r>
           </a:p>
           <a:p>
             <a:pPr lvl="3"/>
             <a:r>
-              <a:rPr lang="en-US" smtClean="0"/>
+              <a:rPr lang="en-US"/>
               <a:t>Fourth level</a:t>
             </a:r>
           </a:p>
           <a:p>
             <a:pPr lvl="4"/>
             <a:r>
-              <a:rPr lang="en-US" smtClean="0"/>
+              <a:rPr lang="en-US"/>
               <a:t>Fifth level</a:t>
             </a:r>
-            <a:endParaRPr lang="en-US"/>
           </a:p>
         </p:txBody>
       </p:sp>
@@ -458,7 +470,7 @@
           <a:p>
             <a:fld id="{5BCAD085-E8A6-8845-BD4E-CB4CCA059FC4}" type="datetimeFigureOut">
               <a:rPr lang="en-US" smtClean="0"/>
-              <a:t>1/27/13</a:t>
+              <a:t>7/2/2026</a:t>
             </a:fld>
             <a:endParaRPr lang="en-US"/>
           </a:p>
@@ -557,10 +569,9 @@
           <a:lstStyle/>
           <a:p>
             <a:r>
-              <a:rPr lang="en-US" smtClean="0"/>
+              <a:rPr lang="en-US"/>
               <a:t>Click to edit Master title style</a:t>
             </a:r>
-            <a:endParaRPr lang="en-US"/>
           </a:p>
         </p:txBody>
       </p:sp>
@@ -586,38 +597,37 @@
           <a:p>
             <a:pPr lvl="0"/>
             <a:r>
-              <a:rPr lang="en-US" smtClean="0"/>
+              <a:rPr lang="en-US"/>
               <a:t>Click to edit Master text styles</a:t>
             </a:r>
           </a:p>
           <a:p>
             <a:pPr lvl="1"/>
             <a:r>
-              <a:rPr lang="en-US" smtClean="0"/>
+              <a:rPr lang="en-US"/>
               <a:t>Second level</a:t>
             </a:r>
           </a:p>
           <a:p>
             <a:pPr lvl="2"/>
             <a:r>
-              <a:rPr lang="en-US" smtClean="0"/>
+              <a:rPr lang="en-US"/>
               <a:t>Third level</a:t>
             </a:r>
           </a:p>
           <a:p>
             <a:pPr lvl="3"/>
             <a:r>
-              <a:rPr lang="en-US" smtClean="0"/>
+              <a:rPr lang="en-US"/>
               <a:t>Fourth level</a:t>
             </a:r>
           </a:p>
           <a:p>
             <a:pPr lvl="4"/>
             <a:r>
-              <a:rPr lang="en-US" smtClean="0"/>
+              <a:rPr lang="en-US"/>
               <a:t>Fifth level</a:t>
             </a:r>
-            <a:endParaRPr lang="en-US"/>
           </a:p>
         </p:txBody>
       </p:sp>
@@ -638,7 +648,7 @@
           <a:p>
             <a:fld id="{5BCAD085-E8A6-8845-BD4E-CB4CCA059FC4}" type="datetimeFigureOut">
               <a:rPr lang="en-US" smtClean="0"/>
-              <a:t>1/27/13</a:t>
+              <a:t>7/2/2026</a:t>
             </a:fld>
             <a:endParaRPr lang="en-US"/>
           </a:p>
@@ -732,10 +742,9 @@
           <a:lstStyle/>
           <a:p>
             <a:r>
-              <a:rPr lang="en-US" smtClean="0"/>
+              <a:rPr lang="en-US"/>
               <a:t>Click to edit Master title style</a:t>
             </a:r>
-            <a:endParaRPr lang="en-US"/>
           </a:p>
         </p:txBody>
       </p:sp>
@@ -756,38 +765,37 @@
           <a:p>
             <a:pPr lvl="0"/>
             <a:r>
-              <a:rPr lang="en-US" smtClean="0"/>
+              <a:rPr lang="en-US"/>
               <a:t>Click to edit Master text styles</a:t>
             </a:r>
           </a:p>
           <a:p>
             <a:pPr lvl="1"/>
             <a:r>
-              <a:rPr lang="en-US" smtClean="0"/>
+              <a:rPr lang="en-US"/>
               <a:t>Second level</a:t>
             </a:r>
           </a:p>
           <a:p>
             <a:pPr lvl="2"/>
             <a:r>
-              <a:rPr lang="en-US" smtClean="0"/>
+              <a:rPr lang="en-US"/>
               <a:t>Third level</a:t>
             </a:r>
           </a:p>
           <a:p>
             <a:pPr lvl="3"/>
             <a:r>
-              <a:rPr lang="en-US" smtClean="0"/>
+              <a:rPr lang="en-US"/>
               <a:t>Fourth level</a:t>
             </a:r>
           </a:p>
           <a:p>
             <a:pPr lvl="4"/>
             <a:r>
-              <a:rPr lang="en-US" smtClean="0"/>
+              <a:rPr lang="en-US"/>
               <a:t>Fifth level</a:t>
             </a:r>
-            <a:endParaRPr lang="en-US"/>
           </a:p>
         </p:txBody>
       </p:sp>
@@ -808,7 +816,7 @@
           <a:p>
             <a:fld id="{5BCAD085-E8A6-8845-BD4E-CB4CCA059FC4}" type="datetimeFigureOut">
               <a:rPr lang="en-US" smtClean="0"/>
-              <a:t>1/27/13</a:t>
+              <a:t>7/2/2026</a:t>
             </a:fld>
             <a:endParaRPr lang="en-US"/>
           </a:p>
@@ -911,10 +919,9 @@
           </a:lstStyle>
           <a:p>
             <a:r>
-              <a:rPr lang="en-US" smtClean="0"/>
+              <a:rPr lang="en-US"/>
               <a:t>Click to edit Master title style</a:t>
             </a:r>
-            <a:endParaRPr lang="en-US"/>
           </a:p>
         </p:txBody>
       </p:sp>
@@ -1031,7 +1038,7 @@
           <a:p>
             <a:pPr lvl="0"/>
             <a:r>
-              <a:rPr lang="en-US" smtClean="0"/>
+              <a:rPr lang="en-US"/>
               <a:t>Click to edit Master text styles</a:t>
             </a:r>
           </a:p>
@@ -1054,7 +1061,7 @@
           <a:p>
             <a:fld id="{5BCAD085-E8A6-8845-BD4E-CB4CCA059FC4}" type="datetimeFigureOut">
               <a:rPr lang="en-US" smtClean="0"/>
-              <a:t>1/27/13</a:t>
+              <a:t>7/2/2026</a:t>
             </a:fld>
             <a:endParaRPr lang="en-US"/>
           </a:p>
@@ -1148,10 +1155,9 @@
           <a:lstStyle/>
           <a:p>
             <a:r>
-              <a:rPr lang="en-US" smtClean="0"/>
+              <a:rPr lang="en-US"/>
               <a:t>Click to edit Master title style</a:t>
             </a:r>
-            <a:endParaRPr lang="en-US"/>
           </a:p>
         </p:txBody>
       </p:sp>
@@ -1205,38 +1211,37 @@
           <a:p>
             <a:pPr lvl="0"/>
             <a:r>
-              <a:rPr lang="en-US" smtClean="0"/>
+              <a:rPr lang="en-US"/>
               <a:t>Click to edit Master text styles</a:t>
             </a:r>
           </a:p>
           <a:p>
             <a:pPr lvl="1"/>
             <a:r>
-              <a:rPr lang="en-US" smtClean="0"/>
+              <a:rPr lang="en-US"/>
               <a:t>Second level</a:t>
             </a:r>
           </a:p>
           <a:p>
             <a:pPr lvl="2"/>
             <a:r>
-              <a:rPr lang="en-US" smtClean="0"/>
+              <a:rPr lang="en-US"/>
               <a:t>Third level</a:t>
             </a:r>
           </a:p>
           <a:p>
             <a:pPr lvl="3"/>
             <a:r>
-              <a:rPr lang="en-US" smtClean="0"/>
+              <a:rPr lang="en-US"/>
               <a:t>Fourth level</a:t>
             </a:r>
           </a:p>
           <a:p>
             <a:pPr lvl="4"/>
             <a:r>
-              <a:rPr lang="en-US" smtClean="0"/>
+              <a:rPr lang="en-US"/>
               <a:t>Fifth level</a:t>
             </a:r>
-            <a:endParaRPr lang="en-US"/>
           </a:p>
         </p:txBody>
       </p:sp>
@@ -1290,38 +1295,37 @@
           <a:p>
             <a:pPr lvl="0"/>
             <a:r>
-              <a:rPr lang="en-US" smtClean="0"/>
+              <a:rPr lang="en-US"/>
               <a:t>Click to edit Master text styles</a:t>
             </a:r>
           </a:p>
           <a:p>
             <a:pPr lvl="1"/>
             <a:r>
-              <a:rPr lang="en-US" smtClean="0"/>
+              <a:rPr lang="en-US"/>
               <a:t>Second level</a:t>
             </a:r>
           </a:p>
           <a:p>
             <a:pPr lvl="2"/>
             <a:r>
-              <a:rPr lang="en-US" smtClean="0"/>
+              <a:rPr lang="en-US"/>
               <a:t>Third level</a:t>
             </a:r>
           </a:p>
           <a:p>
             <a:pPr lvl="3"/>
             <a:r>
-              <a:rPr lang="en-US" smtClean="0"/>
+              <a:rPr lang="en-US"/>
               <a:t>Fourth level</a:t>
             </a:r>
           </a:p>
           <a:p>
             <a:pPr lvl="4"/>
             <a:r>
-              <a:rPr lang="en-US" smtClean="0"/>
+              <a:rPr lang="en-US"/>
               <a:t>Fifth level</a:t>
             </a:r>
-            <a:endParaRPr lang="en-US"/>
           </a:p>
         </p:txBody>
       </p:sp>
@@ -1342,7 +1346,7 @@
           <a:p>
             <a:fld id="{5BCAD085-E8A6-8845-BD4E-CB4CCA059FC4}" type="datetimeFigureOut">
               <a:rPr lang="en-US" smtClean="0"/>
-              <a:t>1/27/13</a:t>
+              <a:t>7/2/2026</a:t>
             </a:fld>
             <a:endParaRPr lang="en-US"/>
           </a:p>
@@ -1440,10 +1444,9 @@
           </a:lstStyle>
           <a:p>
             <a:r>
-              <a:rPr lang="en-US" smtClean="0"/>
+              <a:rPr lang="en-US"/>
               <a:t>Click to edit Master title style</a:t>
             </a:r>
-            <a:endParaRPr lang="en-US"/>
           </a:p>
         </p:txBody>
       </p:sp>
@@ -1506,7 +1509,7 @@
           <a:p>
             <a:pPr lvl="0"/>
             <a:r>
-              <a:rPr lang="en-US" smtClean="0"/>
+              <a:rPr lang="en-US"/>
               <a:t>Click to edit Master text styles</a:t>
             </a:r>
           </a:p>
@@ -1562,38 +1565,37 @@
           <a:p>
             <a:pPr lvl="0"/>
             <a:r>
-              <a:rPr lang="en-US" smtClean="0"/>
+              <a:rPr lang="en-US"/>
               <a:t>Click to edit Master text styles</a:t>
             </a:r>
           </a:p>
           <a:p>
             <a:pPr lvl="1"/>
             <a:r>
-              <a:rPr lang="en-US" smtClean="0"/>
+              <a:rPr lang="en-US"/>
               <a:t>Second level</a:t>
             </a:r>
           </a:p>
           <a:p>
             <a:pPr lvl="2"/>
             <a:r>
-              <a:rPr lang="en-US" smtClean="0"/>
+              <a:rPr lang="en-US"/>
               <a:t>Third level</a:t>
             </a:r>
           </a:p>
           <a:p>
             <a:pPr lvl="3"/>
             <a:r>
-              <a:rPr lang="en-US" smtClean="0"/>
+              <a:rPr lang="en-US"/>
               <a:t>Fourth level</a:t>
             </a:r>
           </a:p>
           <a:p>
             <a:pPr lvl="4"/>
             <a:r>
-              <a:rPr lang="en-US" smtClean="0"/>
+              <a:rPr lang="en-US"/>
               <a:t>Fifth level</a:t>
             </a:r>
-            <a:endParaRPr lang="en-US"/>
           </a:p>
         </p:txBody>
       </p:sp>
@@ -1656,7 +1658,7 @@
           <a:p>
             <a:pPr lvl="0"/>
             <a:r>
-              <a:rPr lang="en-US" smtClean="0"/>
+              <a:rPr lang="en-US"/>
               <a:t>Click to edit Master text styles</a:t>
             </a:r>
           </a:p>
@@ -1712,38 +1714,37 @@
           <a:p>
             <a:pPr lvl="0"/>
             <a:r>
-              <a:rPr lang="en-US" smtClean="0"/>
+              <a:rPr lang="en-US"/>
               <a:t>Click to edit Master text styles</a:t>
             </a:r>
           </a:p>
           <a:p>
             <a:pPr lvl="1"/>
             <a:r>
-              <a:rPr lang="en-US" smtClean="0"/>
+              <a:rPr lang="en-US"/>
               <a:t>Second level</a:t>
             </a:r>
           </a:p>
           <a:p>
             <a:pPr lvl="2"/>
             <a:r>
-              <a:rPr lang="en-US" smtClean="0"/>
+              <a:rPr lang="en-US"/>
               <a:t>Third level</a:t>
             </a:r>
           </a:p>
           <a:p>
             <a:pPr lvl="3"/>
             <a:r>
-              <a:rPr lang="en-US" smtClean="0"/>
+              <a:rPr lang="en-US"/>
               <a:t>Fourth level</a:t>
             </a:r>
           </a:p>
           <a:p>
             <a:pPr lvl="4"/>
             <a:r>
-              <a:rPr lang="en-US" smtClean="0"/>
+              <a:rPr lang="en-US"/>
               <a:t>Fifth level</a:t>
             </a:r>
-            <a:endParaRPr lang="en-US"/>
           </a:p>
         </p:txBody>
       </p:sp>
@@ -1764,7 +1765,7 @@
           <a:p>
             <a:fld id="{5BCAD085-E8A6-8845-BD4E-CB4CCA059FC4}" type="datetimeFigureOut">
               <a:rPr lang="en-US" smtClean="0"/>
-              <a:t>1/27/13</a:t>
+              <a:t>7/2/2026</a:t>
             </a:fld>
             <a:endParaRPr lang="en-US"/>
           </a:p>
@@ -1858,10 +1859,9 @@
           <a:lstStyle/>
           <a:p>
             <a:r>
-              <a:rPr lang="en-US" smtClean="0"/>
+              <a:rPr lang="en-US"/>
               <a:t>Click to edit Master title style</a:t>
             </a:r>
-            <a:endParaRPr lang="en-US"/>
           </a:p>
         </p:txBody>
       </p:sp>
@@ -1882,7 +1882,7 @@
           <a:p>
             <a:fld id="{5BCAD085-E8A6-8845-BD4E-CB4CCA059FC4}" type="datetimeFigureOut">
               <a:rPr lang="en-US" smtClean="0"/>
-              <a:t>1/27/13</a:t>
+              <a:t>7/2/2026</a:t>
             </a:fld>
             <a:endParaRPr lang="en-US"/>
           </a:p>
@@ -1977,7 +1977,7 @@
           <a:p>
             <a:fld id="{5BCAD085-E8A6-8845-BD4E-CB4CCA059FC4}" type="datetimeFigureOut">
               <a:rPr lang="en-US" smtClean="0"/>
-              <a:t>1/27/13</a:t>
+              <a:t>7/2/2026</a:t>
             </a:fld>
             <a:endParaRPr lang="en-US"/>
           </a:p>
@@ -2080,10 +2080,9 @@
           </a:lstStyle>
           <a:p>
             <a:r>
-              <a:rPr lang="en-US" smtClean="0"/>
+              <a:rPr lang="en-US"/>
               <a:t>Click to edit Master title style</a:t>
             </a:r>
-            <a:endParaRPr lang="en-US"/>
           </a:p>
         </p:txBody>
       </p:sp>
@@ -2137,38 +2136,37 @@
           <a:p>
             <a:pPr lvl="0"/>
             <a:r>
-              <a:rPr lang="en-US" smtClean="0"/>
+              <a:rPr lang="en-US"/>
               <a:t>Click to edit Master text styles</a:t>
             </a:r>
           </a:p>
           <a:p>
             <a:pPr lvl="1"/>
             <a:r>
-              <a:rPr lang="en-US" smtClean="0"/>
+              <a:rPr lang="en-US"/>
               <a:t>Second level</a:t>
             </a:r>
           </a:p>
           <a:p>
             <a:pPr lvl="2"/>
             <a:r>
-              <a:rPr lang="en-US" smtClean="0"/>
+              <a:rPr lang="en-US"/>
               <a:t>Third level</a:t>
             </a:r>
           </a:p>
           <a:p>
             <a:pPr lvl="3"/>
             <a:r>
-              <a:rPr lang="en-US" smtClean="0"/>
+              <a:rPr lang="en-US"/>
               <a:t>Fourth level</a:t>
             </a:r>
           </a:p>
           <a:p>
             <a:pPr lvl="4"/>
             <a:r>
-              <a:rPr lang="en-US" smtClean="0"/>
+              <a:rPr lang="en-US"/>
               <a:t>Fifth level</a:t>
             </a:r>
-            <a:endParaRPr lang="en-US"/>
           </a:p>
         </p:txBody>
       </p:sp>
@@ -2231,7 +2229,7 @@
           <a:p>
             <a:pPr lvl="0"/>
             <a:r>
-              <a:rPr lang="en-US" smtClean="0"/>
+              <a:rPr lang="en-US"/>
               <a:t>Click to edit Master text styles</a:t>
             </a:r>
           </a:p>
@@ -2254,7 +2252,7 @@
           <a:p>
             <a:fld id="{5BCAD085-E8A6-8845-BD4E-CB4CCA059FC4}" type="datetimeFigureOut">
               <a:rPr lang="en-US" smtClean="0"/>
-              <a:t>1/27/13</a:t>
+              <a:t>7/2/2026</a:t>
             </a:fld>
             <a:endParaRPr lang="en-US"/>
           </a:p>
@@ -2357,10 +2355,9 @@
           </a:lstStyle>
           <a:p>
             <a:r>
-              <a:rPr lang="en-US" smtClean="0"/>
+              <a:rPr lang="en-US"/>
               <a:t>Click to edit Master title style</a:t>
             </a:r>
-            <a:endParaRPr lang="en-US"/>
           </a:p>
         </p:txBody>
       </p:sp>
@@ -2484,7 +2481,7 @@
           <a:p>
             <a:pPr lvl="0"/>
             <a:r>
-              <a:rPr lang="en-US" smtClean="0"/>
+              <a:rPr lang="en-US"/>
               <a:t>Click to edit Master text styles</a:t>
             </a:r>
           </a:p>
@@ -2507,7 +2504,7 @@
           <a:p>
             <a:fld id="{5BCAD085-E8A6-8845-BD4E-CB4CCA059FC4}" type="datetimeFigureOut">
               <a:rPr lang="en-US" smtClean="0"/>
-              <a:t>1/27/13</a:t>
+              <a:t>7/2/2026</a:t>
             </a:fld>
             <a:endParaRPr lang="en-US"/>
           </a:p>
@@ -2616,10 +2613,9 @@
           <a:lstStyle/>
           <a:p>
             <a:r>
-              <a:rPr lang="en-US" smtClean="0"/>
+              <a:rPr lang="en-US"/>
               <a:t>Click to edit Master title style</a:t>
             </a:r>
-            <a:endParaRPr lang="en-US"/>
           </a:p>
         </p:txBody>
       </p:sp>
@@ -2650,38 +2646,37 @@
           <a:p>
             <a:pPr lvl="0"/>
             <a:r>
-              <a:rPr lang="en-US" smtClean="0"/>
+              <a:rPr lang="en-US"/>
               <a:t>Click to edit Master text styles</a:t>
             </a:r>
           </a:p>
           <a:p>
             <a:pPr lvl="1"/>
             <a:r>
-              <a:rPr lang="en-US" smtClean="0"/>
+              <a:rPr lang="en-US"/>
               <a:t>Second level</a:t>
             </a:r>
           </a:p>
           <a:p>
             <a:pPr lvl="2"/>
             <a:r>
-              <a:rPr lang="en-US" smtClean="0"/>
+              <a:rPr lang="en-US"/>
               <a:t>Third level</a:t>
             </a:r>
           </a:p>
           <a:p>
             <a:pPr lvl="3"/>
             <a:r>
-              <a:rPr lang="en-US" smtClean="0"/>
+              <a:rPr lang="en-US"/>
               <a:t>Fourth level</a:t>
             </a:r>
           </a:p>
           <a:p>
             <a:pPr lvl="4"/>
             <a:r>
-              <a:rPr lang="en-US" smtClean="0"/>
+              <a:rPr lang="en-US"/>
               <a:t>Fifth level</a:t>
             </a:r>
-            <a:endParaRPr lang="en-US"/>
           </a:p>
         </p:txBody>
       </p:sp>
@@ -2720,7 +2715,7 @@
           <a:p>
             <a:fld id="{5BCAD085-E8A6-8845-BD4E-CB4CCA059FC4}" type="datetimeFigureOut">
               <a:rPr lang="en-US" smtClean="0"/>
-              <a:t>1/27/13</a:t>
+              <a:t>7/2/2026</a:t>
             </a:fld>
             <a:endParaRPr lang="en-US"/>
           </a:p>
@@ -3079,7 +3074,7 @@
 </file>
 
 <file path=ppt/slides/slide1.xml><?xml version="1.0" encoding="utf-8"?>
-<p:sld xmlns:a="http://schemas.openxmlformats.org/drawingml/2006/main" xmlns:p="http://schemas.openxmlformats.org/presentationml/2006/main" xmlns:r="http://schemas.openxmlformats.org/officeDocument/2006/relationships">
+<p:sld xmlns:a="http://schemas.openxmlformats.org/drawingml/2006/main" xmlns:r="http://schemas.openxmlformats.org/officeDocument/2006/relationships" xmlns:p="http://schemas.openxmlformats.org/presentationml/2006/main">
   <p:cSld>
     <p:spTree>
       <p:nvGrpSpPr>
@@ -3087,7 +3082,14 @@
         <p:cNvGrpSpPr/>
         <p:nvPr/>
       </p:nvGrpSpPr>
-      <p:grpSpPr/>
+      <p:grpSpPr>
+        <a:xfrm>
+          <a:off x="0" y="0"/>
+          <a:ext cx="0" cy="0"/>
+          <a:chOff x="0" y="0"/>
+          <a:chExt cx="0" cy="0"/>
+        </a:xfrm>
+      </p:grpSpPr>
       <p:sp>
         <p:nvSpPr>
           <p:cNvPr id="2" name="Rectangle 1"/>
@@ -3129,6 +3131,7 @@
           <a:lstStyle/>
           <a:p>
             <a:pPr algn="ctr"/>
+            <a:endParaRPr/>
           </a:p>
         </p:txBody>
       </p:sp>
@@ -3173,6 +3176,7 @@
           <a:lstStyle/>
           <a:p>
             <a:pPr algn="ctr"/>
+            <a:endParaRPr/>
           </a:p>
         </p:txBody>
       </p:sp>
@@ -3185,7 +3189,7 @@
         <p:spPr>
           <a:xfrm>
             <a:off x="502920" y="274320"/>
-            <a:ext cx="8229600" cy="237744"/>
+            <a:ext cx="8229600" cy="161583"/>
           </a:xfrm>
           <a:prstGeom prst="rect">
             <a:avLst/>
@@ -3193,7 +3197,7 @@
           <a:noFill/>
         </p:spPr>
         <p:txBody>
-          <a:bodyPr wrap="square" anchor="t" lIns="0" rIns="0" tIns="0" bIns="0">
+          <a:bodyPr wrap="square" lIns="0" tIns="0" rIns="0" bIns="0" anchor="t">
             <a:spAutoFit/>
           </a:bodyPr>
           <a:lstStyle/>
@@ -3204,14 +3208,29 @@
               </a:lnSpc>
             </a:pPr>
             <a:r>
-              <a:rPr sz="1050" b="0" spc="140">
+              <a:rPr sz="1050" b="0" spc="140" dirty="0">
                 <a:solidFill>
                   <a:srgbClr val="0E767E"/>
                 </a:solidFill>
                 <a:latin typeface="Consolas"/>
               </a:rPr>
-              <a:t>MONARCH · CONTROLS → PYTHON MIGRATION</a:t>
-            </a:r>
+              <a:t>CONTROLS → PYTHON </a:t>
+            </a:r>
+            <a:r>
+              <a:rPr lang="en-US" sz="1050" b="0" spc="140" dirty="0">
+                <a:solidFill>
+                  <a:srgbClr val="0E767E"/>
+                </a:solidFill>
+                <a:latin typeface="Consolas"/>
+              </a:rPr>
+              <a:t>/ LABVIEW INTEGRATION</a:t>
+            </a:r>
+            <a:endParaRPr sz="1050" b="0" spc="140" dirty="0">
+              <a:solidFill>
+                <a:srgbClr val="0E767E"/>
+              </a:solidFill>
+              <a:latin typeface="Consolas"/>
+            </a:endParaRPr>
           </a:p>
         </p:txBody>
       </p:sp>
@@ -3224,7 +3243,7 @@
         <p:spPr>
           <a:xfrm>
             <a:off x="502920" y="512064"/>
-            <a:ext cx="11155680" cy="822960"/>
+            <a:ext cx="11155680" cy="446276"/>
           </a:xfrm>
           <a:prstGeom prst="rect">
             <a:avLst/>
@@ -3232,7 +3251,7 @@
           <a:noFill/>
         </p:spPr>
         <p:txBody>
-          <a:bodyPr wrap="square" anchor="t" lIns="0" rIns="0" tIns="0" bIns="0">
+          <a:bodyPr wrap="square" lIns="0" tIns="0" rIns="0" bIns="0" anchor="t">
             <a:spAutoFit/>
           </a:bodyPr>
           <a:lstStyle/>
@@ -3243,14 +3262,29 @@
               </a:lnSpc>
             </a:pPr>
             <a:r>
-              <a:rPr sz="2900" b="1">
+              <a:rPr sz="2900" b="1" dirty="0">
                 <a:solidFill>
                   <a:srgbClr val="16222D"/>
                 </a:solidFill>
                 <a:latin typeface="Segoe UI"/>
               </a:rPr>
-              <a:t>The new Python layer is talking to LabVIEW — live</a:t>
-            </a:r>
+              <a:t>The new Python layer is talking to LabVIE</a:t>
+            </a:r>
+            <a:r>
+              <a:rPr lang="en-US" sz="2900" b="1" dirty="0">
+                <a:solidFill>
+                  <a:srgbClr val="16222D"/>
+                </a:solidFill>
+                <a:latin typeface="Segoe UI"/>
+              </a:rPr>
+              <a:t>W</a:t>
+            </a:r>
+            <a:endParaRPr sz="2900" b="1" dirty="0">
+              <a:solidFill>
+                <a:srgbClr val="16222D"/>
+              </a:solidFill>
+              <a:latin typeface="Segoe UI"/>
+            </a:endParaRPr>
           </a:p>
         </p:txBody>
       </p:sp>
@@ -3263,7 +3297,7 @@
         <p:spPr>
           <a:xfrm>
             <a:off x="502920" y="1389888"/>
-            <a:ext cx="8138160" cy="640080"/>
+            <a:ext cx="8138160" cy="446469"/>
           </a:xfrm>
           <a:prstGeom prst="rect">
             <a:avLst/>
@@ -3271,7 +3305,7 @@
           <a:noFill/>
         </p:spPr>
         <p:txBody>
-          <a:bodyPr wrap="square" anchor="t" lIns="0" rIns="0" tIns="0" bIns="0">
+          <a:bodyPr wrap="square" lIns="0" tIns="0" rIns="0" bIns="0" anchor="t">
             <a:spAutoFit/>
           </a:bodyPr>
           <a:lstStyle/>
@@ -3282,16 +3316,43 @@
               </a:lnSpc>
             </a:pPr>
             <a:r>
-              <a:rPr sz="1350" b="0">
+              <a:rPr sz="1350" b="0" dirty="0">
                 <a:solidFill>
                   <a:srgbClr val="5C6B78"/>
                 </a:solidFill>
                 <a:latin typeface="Segoe UI"/>
               </a:rPr>
-              <a:t>First end-to-end connection test </a:t>
-            </a:r>
-            <a:r>
-              <a:rPr sz="1350" b="1">
+              <a:t>First end-to-end </a:t>
+            </a:r>
+            <a:r>
+              <a:rPr lang="en-US" sz="1350" b="0" dirty="0">
+                <a:solidFill>
+                  <a:srgbClr val="5C6B78"/>
+                </a:solidFill>
+                <a:latin typeface="Segoe UI"/>
+              </a:rPr>
+              <a:t>“Hello </a:t>
+            </a:r>
+            <a:r>
+              <a:rPr lang="en-US" sz="1350" dirty="0">
+                <a:solidFill>
+                  <a:srgbClr val="5C6B78"/>
+                </a:solidFill>
+                <a:latin typeface="Segoe UI"/>
+              </a:rPr>
+              <a:t>VI” </a:t>
+            </a:r>
+            <a:r>
+              <a:rPr sz="1350" b="0" dirty="0">
+                <a:solidFill>
+                  <a:srgbClr val="5C6B78"/>
+                </a:solidFill>
+                <a:latin typeface="Segoe UI"/>
+              </a:rPr>
+              <a:t>connection test </a:t>
+            </a:r>
+            <a:r>
+              <a:rPr sz="1350" b="1" dirty="0">
                 <a:solidFill>
                   <a:srgbClr val="16222D"/>
                 </a:solidFill>
@@ -3300,14 +3361,29 @@
               <a:t>passed</a:t>
             </a:r>
             <a:r>
-              <a:rPr sz="1350" b="0">
+              <a:rPr sz="1350" b="0" dirty="0">
                 <a:solidFill>
                   <a:srgbClr val="5C6B78"/>
                 </a:solidFill>
                 <a:latin typeface="Segoe UI"/>
               </a:rPr>
-              <a:t>: the two systems exchanged data both ways, once a second, running side by side on the control-room PC — with no change to the safety-critical LabVIEW control.</a:t>
-            </a:r>
+              <a:t>: the two systems exchanged data both ways, once a second, running side by side on the control-room PC</a:t>
+            </a:r>
+            <a:r>
+              <a:rPr lang="en-US" sz="1350" dirty="0">
+                <a:solidFill>
+                  <a:srgbClr val="5C6B78"/>
+                </a:solidFill>
+                <a:latin typeface="Segoe UI"/>
+              </a:rPr>
+              <a:t>.</a:t>
+            </a:r>
+            <a:endParaRPr sz="1350" b="0" dirty="0">
+              <a:solidFill>
+                <a:srgbClr val="5C6B78"/>
+              </a:solidFill>
+              <a:latin typeface="Segoe UI"/>
+            </a:endParaRPr>
           </a:p>
         </p:txBody>
       </p:sp>
@@ -3328,7 +3404,7 @@
           <a:noFill/>
         </p:spPr>
         <p:txBody>
-          <a:bodyPr wrap="square" anchor="t" lIns="0" rIns="0" tIns="0" bIns="0">
+          <a:bodyPr wrap="square" lIns="0" tIns="0" rIns="0" bIns="0" anchor="t">
             <a:spAutoFit/>
           </a:bodyPr>
           <a:lstStyle/>
@@ -3394,7 +3470,7 @@
         <p:spPr>
           <a:xfrm>
             <a:off x="502920" y="2560320"/>
-            <a:ext cx="5349240" cy="1600200"/>
+            <a:ext cx="5349240" cy="1487908"/>
           </a:xfrm>
           <a:prstGeom prst="rect">
             <a:avLst/>
@@ -3402,7 +3478,7 @@
           <a:noFill/>
         </p:spPr>
         <p:txBody>
-          <a:bodyPr wrap="square" anchor="t" lIns="0" rIns="0" tIns="0" bIns="0">
+          <a:bodyPr wrap="square" lIns="0" tIns="0" rIns="0" bIns="0" anchor="t">
             <a:spAutoFit/>
           </a:bodyPr>
           <a:lstStyle/>
@@ -3416,7 +3492,7 @@
               </a:spcAft>
             </a:pPr>
             <a:r>
-              <a:rPr sz="1300" b="1">
+              <a:rPr sz="1300" b="1" dirty="0">
                 <a:solidFill>
                   <a:srgbClr val="0E767E"/>
                 </a:solidFill>
@@ -3425,7 +3501,7 @@
               <a:t>▪  </a:t>
             </a:r>
             <a:r>
-              <a:rPr sz="1300" b="0">
+              <a:rPr sz="1300" b="0" dirty="0">
                 <a:solidFill>
                   <a:srgbClr val="16222D"/>
                 </a:solidFill>
@@ -3434,7 +3510,7 @@
               <a:t>Built a minimal </a:t>
             </a:r>
             <a:r>
-              <a:rPr sz="1300" b="1">
+              <a:rPr sz="1300" b="1" dirty="0">
                 <a:solidFill>
                   <a:srgbClr val="16222D"/>
                 </a:solidFill>
@@ -3443,7 +3519,7 @@
               <a:t>“hello” link</a:t>
             </a:r>
             <a:r>
-              <a:rPr sz="1300" b="0">
+              <a:rPr sz="1300" b="0" dirty="0">
                 <a:solidFill>
                   <a:srgbClr val="16222D"/>
                 </a:solidFill>
@@ -3462,7 +3538,7 @@
               </a:spcAft>
             </a:pPr>
             <a:r>
-              <a:rPr sz="1300" b="1">
+              <a:rPr sz="1300" b="1" dirty="0">
                 <a:solidFill>
                   <a:srgbClr val="0E767E"/>
                 </a:solidFill>
@@ -3471,7 +3547,7 @@
               <a:t>▪  </a:t>
             </a:r>
             <a:r>
-              <a:rPr sz="1300" b="0">
+              <a:rPr sz="1300" b="0" dirty="0">
                 <a:solidFill>
                   <a:srgbClr val="16222D"/>
                 </a:solidFill>
@@ -3480,7 +3556,7 @@
               <a:t>LabVIEW streams a live value to Python </a:t>
             </a:r>
             <a:r>
-              <a:rPr sz="1300" b="1">
+              <a:rPr sz="1300" b="1" dirty="0">
                 <a:solidFill>
                   <a:srgbClr val="16222D"/>
                 </a:solidFill>
@@ -3489,7 +3565,7 @@
               <a:t>once per second</a:t>
             </a:r>
             <a:r>
-              <a:rPr sz="1300" b="0">
+              <a:rPr sz="1300" b="0" dirty="0">
                 <a:solidFill>
                   <a:srgbClr val="16222D"/>
                 </a:solidFill>
@@ -3498,7 +3574,7 @@
               <a:t>; Python sends commands back and LabVIEW </a:t>
             </a:r>
             <a:r>
-              <a:rPr sz="1300" b="1">
+              <a:rPr sz="1300" b="1" dirty="0">
                 <a:solidFill>
                   <a:srgbClr val="16222D"/>
                 </a:solidFill>
@@ -3507,7 +3583,7 @@
               <a:t>acknowledges every one</a:t>
             </a:r>
             <a:r>
-              <a:rPr sz="1300" b="0">
+              <a:rPr sz="1300" b="0" dirty="0">
                 <a:solidFill>
                   <a:srgbClr val="16222D"/>
                 </a:solidFill>
@@ -3526,7 +3602,7 @@
               </a:spcAft>
             </a:pPr>
             <a:r>
-              <a:rPr sz="1300" b="1">
+              <a:rPr sz="1300" b="1" dirty="0">
                 <a:solidFill>
                   <a:srgbClr val="0E767E"/>
                 </a:solidFill>
@@ -3535,16 +3611,34 @@
               <a:t>▪  </a:t>
             </a:r>
             <a:r>
-              <a:rPr sz="1300" b="0">
+              <a:rPr sz="1300" b="0" dirty="0">
                 <a:solidFill>
                   <a:srgbClr val="16222D"/>
                 </a:solidFill>
                 <a:latin typeface="Segoe UI"/>
               </a:rPr>
-              <a:t>Both ran on the same PC at once — and </a:t>
-            </a:r>
-            <a:r>
-              <a:rPr sz="1300" b="1">
+              <a:t>Both ran on the same PC</a:t>
+            </a:r>
+            <a:r>
+              <a:rPr lang="en-US" sz="1300" b="0" dirty="0">
+                <a:solidFill>
+                  <a:srgbClr val="16222D"/>
+                </a:solidFill>
+                <a:latin typeface="Segoe UI"/>
+              </a:rPr>
+              <a:t>: </a:t>
+            </a:r>
+            <a:r>
+              <a:rPr sz="1300" b="0" dirty="0">
+                <a:solidFill>
+                  <a:srgbClr val="16222D"/>
+                </a:solidFill>
+                <a:latin typeface="Segoe UI"/>
+              </a:rPr>
+              <a:t>and </a:t>
+            </a:r>
+            <a:r>
+              <a:rPr sz="1300" b="1" dirty="0">
                 <a:solidFill>
                   <a:srgbClr val="16222D"/>
                 </a:solidFill>
@@ -3553,7 +3647,7 @@
               <a:t>either side can restart</a:t>
             </a:r>
             <a:r>
-              <a:rPr sz="1300" b="0">
+              <a:rPr sz="1300" b="0" dirty="0">
                 <a:solidFill>
                   <a:srgbClr val="16222D"/>
                 </a:solidFill>
@@ -3566,52 +3660,13 @@
       </p:sp>
       <p:sp>
         <p:nvSpPr>
-          <p:cNvPr id="10" name="TextBox 9"/>
-          <p:cNvSpPr txBox="1"/>
-          <p:nvPr/>
-        </p:nvSpPr>
-        <p:spPr>
-          <a:xfrm>
-            <a:off x="502920" y="4187952"/>
-            <a:ext cx="5349240" cy="219456"/>
-          </a:xfrm>
-          <a:prstGeom prst="rect">
-            <a:avLst/>
-          </a:prstGeom>
-          <a:noFill/>
-        </p:spPr>
-        <p:txBody>
-          <a:bodyPr wrap="square" anchor="t" lIns="0" rIns="0" tIns="0" bIns="0">
-            <a:spAutoFit/>
-          </a:bodyPr>
-          <a:lstStyle/>
-          <a:p>
-            <a:pPr algn="ctr">
-              <a:lnSpc>
-                <a:spcPct val="100000"/>
-              </a:lnSpc>
-            </a:pPr>
-            <a:r>
-              <a:rPr sz="900" b="0" spc="90">
-                <a:solidFill>
-                  <a:srgbClr val="5C6B78"/>
-                </a:solidFill>
-                <a:latin typeface="Consolas"/>
-              </a:rPr>
-              <a:t>ONE CONTROL-ROOM PC · BOTH RUNNING</a:t>
-            </a:r>
-          </a:p>
-        </p:txBody>
-      </p:sp>
-      <p:sp>
-        <p:nvSpPr>
           <p:cNvPr id="11" name="Rounded Rectangle 10"/>
           <p:cNvSpPr/>
           <p:nvPr/>
         </p:nvSpPr>
         <p:spPr>
           <a:xfrm>
-            <a:off x="502920" y="4462272"/>
+            <a:off x="502919" y="4194531"/>
             <a:ext cx="1828800" cy="932688"/>
           </a:xfrm>
           <a:prstGeom prst="roundRect">
@@ -3644,7 +3699,7 @@
           </a:fontRef>
         </p:style>
         <p:txBody>
-          <a:bodyPr rtlCol="0" anchor="ctr" wrap="square"/>
+          <a:bodyPr wrap="square" rtlCol="0" anchor="ctr"/>
           <a:lstStyle/>
           <a:p>
             <a:pPr algn="ctr">
@@ -3652,15 +3707,12 @@
                 <a:spcPts val="0"/>
               </a:spcAft>
             </a:pPr>
-            <a:r>
-              <a:rPr sz="900" b="0">
-                <a:solidFill>
-                  <a:srgbClr val="5B46C9"/>
-                </a:solidFill>
-                <a:latin typeface="Consolas"/>
-              </a:rPr>
-              <a:t>NEW</a:t>
-            </a:r>
+            <a:endParaRPr sz="900" b="0" dirty="0">
+              <a:solidFill>
+                <a:srgbClr val="5B46C9"/>
+              </a:solidFill>
+              <a:latin typeface="Consolas"/>
+            </a:endParaRPr>
           </a:p>
           <a:p>
             <a:pPr algn="ctr">
@@ -3669,7 +3721,7 @@
               </a:spcAft>
             </a:pPr>
             <a:r>
-              <a:rPr sz="1500" b="1">
+              <a:rPr sz="1500" b="1" dirty="0">
                 <a:solidFill>
                   <a:srgbClr val="5B46C9"/>
                 </a:solidFill>
@@ -3685,14 +3737,20 @@
               </a:spcAft>
             </a:pPr>
             <a:r>
-              <a:rPr sz="950" b="0">
+              <a:rPr lang="en-US" sz="950" b="0" dirty="0">
                 <a:solidFill>
                   <a:srgbClr val="5B46C9"/>
                 </a:solidFill>
                 <a:latin typeface="Segoe UI"/>
               </a:rPr>
-              <a:t>supervisory layer</a:t>
-            </a:r>
+              <a:t>script</a:t>
+            </a:r>
+            <a:endParaRPr sz="950" b="0" dirty="0">
+              <a:solidFill>
+                <a:srgbClr val="5B46C9"/>
+              </a:solidFill>
+              <a:latin typeface="Segoe UI"/>
+            </a:endParaRPr>
           </a:p>
         </p:txBody>
       </p:sp>
@@ -3704,7 +3762,7 @@
         </p:nvSpPr>
         <p:spPr>
           <a:xfrm>
-            <a:off x="4023360" y="4462272"/>
+            <a:off x="4023359" y="4194531"/>
             <a:ext cx="1828800" cy="932688"/>
           </a:xfrm>
           <a:prstGeom prst="roundRect">
@@ -3737,7 +3795,7 @@
           </a:fontRef>
         </p:style>
         <p:txBody>
-          <a:bodyPr rtlCol="0" anchor="ctr" wrap="square"/>
+          <a:bodyPr wrap="square" rtlCol="0" anchor="ctr"/>
           <a:lstStyle/>
           <a:p>
             <a:pPr algn="ctr">
@@ -3746,14 +3804,20 @@
               </a:spcAft>
             </a:pPr>
             <a:r>
-              <a:rPr sz="900" b="0">
+              <a:rPr lang="en-US" sz="900" b="0" dirty="0">
                 <a:solidFill>
                   <a:srgbClr val="0E767E"/>
                 </a:solidFill>
                 <a:latin typeface="Consolas"/>
               </a:rPr>
-              <a:t>EXISTING</a:t>
-            </a:r>
+              <a:t>Minimal ‘Hello VI’</a:t>
+            </a:r>
+            <a:endParaRPr sz="900" b="0" dirty="0">
+              <a:solidFill>
+                <a:srgbClr val="0E767E"/>
+              </a:solidFill>
+              <a:latin typeface="Consolas"/>
+            </a:endParaRPr>
           </a:p>
           <a:p>
             <a:pPr algn="ctr">
@@ -3762,139 +3826,13 @@
               </a:spcAft>
             </a:pPr>
             <a:r>
-              <a:rPr sz="1500" b="1">
+              <a:rPr sz="1500" b="1" dirty="0">
                 <a:solidFill>
                   <a:srgbClr val="0E767E"/>
                 </a:solidFill>
                 <a:latin typeface="Segoe UI"/>
               </a:rPr>
               <a:t>LabVIEW</a:t>
-            </a:r>
-          </a:p>
-          <a:p>
-            <a:pPr algn="ctr">
-              <a:spcAft>
-                <a:spcPts val="0"/>
-              </a:spcAft>
-            </a:pPr>
-            <a:r>
-              <a:rPr sz="950" b="0">
-                <a:solidFill>
-                  <a:srgbClr val="0E767E"/>
-                </a:solidFill>
-                <a:latin typeface="Segoe UI"/>
-              </a:rPr>
-              <a:t>engine control</a:t>
-            </a:r>
-          </a:p>
-        </p:txBody>
-      </p:sp>
-      <p:sp>
-        <p:nvSpPr>
-          <p:cNvPr id="13" name="TextBox 12"/>
-          <p:cNvSpPr txBox="1"/>
-          <p:nvPr/>
-        </p:nvSpPr>
-        <p:spPr>
-          <a:xfrm>
-            <a:off x="2377439" y="4480560"/>
-            <a:ext cx="1600200" cy="914400"/>
-          </a:xfrm>
-          <a:prstGeom prst="rect">
-            <a:avLst/>
-          </a:prstGeom>
-          <a:noFill/>
-        </p:spPr>
-        <p:txBody>
-          <a:bodyPr wrap="square" anchor="ctr" lIns="0" rIns="0" tIns="0" bIns="0">
-            <a:spAutoFit/>
-          </a:bodyPr>
-          <a:lstStyle/>
-          <a:p>
-            <a:pPr algn="ctr">
-              <a:lnSpc>
-                <a:spcPct val="135000"/>
-              </a:lnSpc>
-            </a:pPr>
-            <a:r>
-              <a:rPr sz="950" b="1">
-                <a:solidFill>
-                  <a:srgbClr val="0E767E"/>
-                </a:solidFill>
-                <a:latin typeface="Consolas"/>
-              </a:rPr>
-              <a:t>live data →</a:t>
-            </a:r>
-          </a:p>
-          <a:p>
-            <a:pPr algn="ctr">
-              <a:lnSpc>
-                <a:spcPct val="135000"/>
-              </a:lnSpc>
-            </a:pPr>
-            <a:r>
-              <a:rPr sz="950" b="1">
-                <a:solidFill>
-                  <a:srgbClr val="5B46C9"/>
-                </a:solidFill>
-                <a:latin typeface="Consolas"/>
-              </a:rPr>
-              <a:t>← commands</a:t>
-            </a:r>
-          </a:p>
-          <a:p>
-            <a:pPr algn="ctr">
-              <a:lnSpc>
-                <a:spcPct val="135000"/>
-              </a:lnSpc>
-            </a:pPr>
-            <a:r>
-              <a:rPr sz="950" b="0">
-                <a:solidFill>
-                  <a:srgbClr val="5C6B78"/>
-                </a:solidFill>
-                <a:latin typeface="Consolas"/>
-              </a:rPr>
-              <a:t>♥ heartbeat</a:t>
-            </a:r>
-          </a:p>
-        </p:txBody>
-      </p:sp>
-      <p:sp>
-        <p:nvSpPr>
-          <p:cNvPr id="14" name="TextBox 13"/>
-          <p:cNvSpPr txBox="1"/>
-          <p:nvPr/>
-        </p:nvSpPr>
-        <p:spPr>
-          <a:xfrm>
-            <a:off x="6263640" y="2121408"/>
-            <a:ext cx="5422392" cy="228600"/>
-          </a:xfrm>
-          <a:prstGeom prst="rect">
-            <a:avLst/>
-          </a:prstGeom>
-          <a:noFill/>
-        </p:spPr>
-        <p:txBody>
-          <a:bodyPr wrap="square" anchor="t" lIns="0" rIns="0" tIns="0" bIns="0">
-            <a:spAutoFit/>
-          </a:bodyPr>
-          <a:lstStyle/>
-          <a:p>
-            <a:pPr algn="l">
-              <a:lnSpc>
-                <a:spcPct val="100000"/>
-              </a:lnSpc>
-            </a:pPr>
-            <a:r>
-              <a:rPr sz="1050" b="0" spc="110">
-                <a:solidFill>
-                  <a:srgbClr val="5C6B78"/>
-                </a:solidFill>
-                <a:latin typeface="Consolas"/>
-              </a:rPr>
-              <a:t>PROOF IT WORKED</a:t>
             </a:r>
           </a:p>
         </p:txBody>
@@ -4034,6 +3972,7 @@
           <a:lstStyle/>
           <a:p>
             <a:pPr algn="ctr"/>
+            <a:endParaRPr/>
           </a:p>
         </p:txBody>
       </p:sp>
@@ -4078,7 +4017,7 @@
           <a:noFill/>
         </p:spPr>
         <p:txBody>
-          <a:bodyPr wrap="square" anchor="t" lIns="0" rIns="0" tIns="0" bIns="0">
+          <a:bodyPr wrap="square" lIns="0" tIns="0" rIns="0" bIns="0" anchor="t">
             <a:spAutoFit/>
           </a:bodyPr>
           <a:lstStyle/>
@@ -4141,7 +4080,7 @@
           <a:noFill/>
         </p:spPr>
         <p:txBody>
-          <a:bodyPr wrap="square" anchor="t" lIns="0" rIns="0" tIns="0" bIns="0">
+          <a:bodyPr wrap="square" lIns="0" tIns="0" rIns="0" bIns="0" anchor="t">
             <a:spAutoFit/>
           </a:bodyPr>
           <a:lstStyle/>
@@ -4166,13 +4105,15 @@
       <p:cxnSp>
         <p:nvCxnSpPr>
           <p:cNvPr id="22" name="Connector 21"/>
-          <p:cNvCxnSpPr/>
+          <p:cNvCxnSpPr>
+            <a:cxnSpLocks/>
+          </p:cNvCxnSpPr>
           <p:nvPr/>
         </p:nvCxnSpPr>
         <p:spPr>
           <a:xfrm>
-            <a:off x="502920" y="5705856"/>
-            <a:ext cx="11185855" cy="0"/>
+            <a:off x="6164580" y="5707724"/>
+            <a:ext cx="5524195" cy="10832"/>
           </a:xfrm>
           <a:prstGeom prst="bentConnector3">
             <a:avLst/>
@@ -4206,7 +4147,7 @@
         </p:nvSpPr>
         <p:spPr>
           <a:xfrm>
-            <a:off x="502920" y="5760720"/>
+            <a:off x="6431280" y="5806439"/>
             <a:ext cx="2286000" cy="201168"/>
           </a:xfrm>
           <a:prstGeom prst="rect">
@@ -4215,7 +4156,7 @@
           <a:noFill/>
         </p:spPr>
         <p:txBody>
-          <a:bodyPr wrap="square" anchor="t" lIns="0" rIns="0" tIns="0" bIns="0">
+          <a:bodyPr wrap="square" lIns="0" tIns="0" rIns="0" bIns="0" anchor="t">
             <a:spAutoFit/>
           </a:bodyPr>
           <a:lstStyle/>
@@ -4226,7 +4167,7 @@
               </a:lnSpc>
             </a:pPr>
             <a:r>
-              <a:rPr sz="900" b="0" spc="110">
+              <a:rPr sz="900" b="0" spc="110" dirty="0">
                 <a:solidFill>
                   <a:srgbClr val="5C6B78"/>
                 </a:solidFill>
@@ -4245,7 +4186,7 @@
         </p:nvSpPr>
         <p:spPr>
           <a:xfrm>
-            <a:off x="502920" y="5989320"/>
+            <a:off x="6431280" y="6035039"/>
             <a:ext cx="1828800" cy="719999"/>
           </a:xfrm>
           <a:prstGeom prst="rect">
@@ -4280,6 +4221,7 @@
           <a:lstStyle/>
           <a:p>
             <a:pPr algn="ctr"/>
+            <a:endParaRPr/>
           </a:p>
         </p:txBody>
       </p:sp>
@@ -4299,7 +4241,7 @@
         </p:blipFill>
         <p:spPr>
           <a:xfrm>
-            <a:off x="548640" y="6035040"/>
+            <a:off x="6477000" y="6080759"/>
             <a:ext cx="1737360" cy="628560"/>
           </a:xfrm>
           <a:prstGeom prst="rect">
@@ -4315,7 +4257,7 @@
         </p:nvSpPr>
         <p:spPr>
           <a:xfrm>
-            <a:off x="2478024" y="6144768"/>
+            <a:off x="8406384" y="6190487"/>
             <a:ext cx="1051560" cy="548640"/>
           </a:xfrm>
           <a:prstGeom prst="rect">
@@ -4324,7 +4266,7 @@
           <a:noFill/>
         </p:spPr>
         <p:txBody>
-          <a:bodyPr wrap="square" anchor="t" lIns="0" rIns="0" tIns="0" bIns="0">
+          <a:bodyPr wrap="square" lIns="0" tIns="0" rIns="0" bIns="0" anchor="t">
             <a:spAutoFit/>
           </a:bodyPr>
           <a:lstStyle/>
@@ -4335,7 +4277,7 @@
               </a:lnSpc>
             </a:pPr>
             <a:r>
-              <a:rPr sz="900" b="0">
+              <a:rPr sz="900" b="0" dirty="0">
                 <a:solidFill>
                   <a:srgbClr val="5C6B78"/>
                 </a:solidFill>
@@ -4355,7 +4297,7 @@
         </p:nvSpPr>
         <p:spPr>
           <a:xfrm>
-            <a:off x="4160520" y="5779007"/>
+            <a:off x="2490824" y="5649394"/>
             <a:ext cx="1373428" cy="310896"/>
           </a:xfrm>
           <a:prstGeom prst="roundRect">
@@ -4393,7 +4335,7 @@
           <a:p>
             <a:pPr algn="ctr"/>
             <a:r>
-              <a:rPr sz="1100">
+              <a:rPr sz="1100" dirty="0">
                 <a:solidFill>
                   <a:srgbClr val="1C914F"/>
                 </a:solidFill>
@@ -4402,7 +4344,7 @@
               <a:t>✓ </a:t>
             </a:r>
             <a:r>
-              <a:rPr sz="1100">
+              <a:rPr sz="1100" dirty="0">
                 <a:solidFill>
                   <a:srgbClr val="16222D"/>
                 </a:solidFill>
@@ -4421,7 +4363,7 @@
         </p:nvSpPr>
         <p:spPr>
           <a:xfrm>
-            <a:off x="5661964" y="5779007"/>
+            <a:off x="2470098" y="5275531"/>
             <a:ext cx="1458468" cy="310896"/>
           </a:xfrm>
           <a:prstGeom prst="roundRect">
@@ -4459,7 +4401,7 @@
           <a:p>
             <a:pPr algn="ctr"/>
             <a:r>
-              <a:rPr sz="1100">
+              <a:rPr sz="1100" dirty="0">
                 <a:solidFill>
                   <a:srgbClr val="1C914F"/>
                 </a:solidFill>
@@ -4468,7 +4410,7 @@
               <a:t>✓ </a:t>
             </a:r>
             <a:r>
-              <a:rPr sz="1100">
+              <a:rPr sz="1100" dirty="0">
                 <a:solidFill>
                   <a:srgbClr val="16222D"/>
                 </a:solidFill>
@@ -4487,7 +4429,7 @@
         </p:nvSpPr>
         <p:spPr>
           <a:xfrm>
-            <a:off x="7248448" y="5779007"/>
+            <a:off x="2410204" y="4901668"/>
             <a:ext cx="1543507" cy="310896"/>
           </a:xfrm>
           <a:prstGeom prst="roundRect">
@@ -4562,7 +4504,7 @@
           <a:noFill/>
         </p:spPr>
         <p:txBody>
-          <a:bodyPr wrap="square" anchor="t" lIns="0" rIns="0" tIns="0" bIns="0">
+          <a:bodyPr wrap="square" lIns="0" tIns="0" rIns="0" bIns="0" anchor="t">
             <a:spAutoFit/>
           </a:bodyPr>
           <a:lstStyle/>
@@ -4584,79 +4526,86 @@
           </a:p>
         </p:txBody>
       </p:sp>
-      <p:sp>
-        <p:nvSpPr>
-          <p:cNvPr id="31" name="TextBox 30"/>
-          <p:cNvSpPr txBox="1"/>
+      <p:cxnSp>
+        <p:nvCxnSpPr>
+          <p:cNvPr id="33" name="Straight Arrow Connector 32">
+            <a:extLst>
+              <a:ext uri="{FF2B5EF4-FFF2-40B4-BE49-F238E27FC236}">
+                <a16:creationId xmlns:a16="http://schemas.microsoft.com/office/drawing/2014/main" id="{DAE58E44-A8E3-EB70-7CC9-4A0F2D6A9695}"/>
+              </a:ext>
+            </a:extLst>
+          </p:cNvPr>
+          <p:cNvCxnSpPr/>
           <p:nvPr/>
-        </p:nvSpPr>
+        </p:nvCxnSpPr>
         <p:spPr>
           <a:xfrm>
-            <a:off x="4160520" y="6236208"/>
-            <a:ext cx="7360920" cy="502920"/>
-          </a:xfrm>
-          <a:prstGeom prst="rect">
+            <a:off x="2659378" y="4540479"/>
+            <a:ext cx="960120" cy="0"/>
+          </a:xfrm>
+          <a:prstGeom prst="straightConnector1">
             <a:avLst/>
           </a:prstGeom>
-          <a:noFill/>
-        </p:spPr>
-        <p:txBody>
-          <a:bodyPr wrap="square" anchor="t" lIns="0" rIns="0" tIns="0" bIns="0">
-            <a:spAutoFit/>
-          </a:bodyPr>
-          <a:lstStyle/>
-          <a:p>
-            <a:pPr algn="l">
-              <a:lnSpc>
-                <a:spcPct val="118000"/>
-              </a:lnSpc>
-            </a:pPr>
-            <a:r>
-              <a:rPr sz="1100" b="1">
-                <a:solidFill>
-                  <a:srgbClr val="16222D"/>
-                </a:solidFill>
-                <a:latin typeface="Segoe UI"/>
-              </a:rPr>
-              <a:t>Why it matters:  </a:t>
-            </a:r>
-            <a:r>
-              <a:rPr sz="1100" b="0">
-                <a:solidFill>
-                  <a:srgbClr val="5C6B78"/>
-                </a:solidFill>
-                <a:latin typeface="Segoe UI"/>
-              </a:rPr>
-              <a:t>connecting the two systems was the biggest unknown — now proven.</a:t>
-            </a:r>
-          </a:p>
-          <a:p>
-            <a:pPr algn="l">
-              <a:lnSpc>
-                <a:spcPct val="118000"/>
-              </a:lnSpc>
-            </a:pPr>
-            <a:r>
-              <a:rPr sz="1100" b="1">
-                <a:solidFill>
-                  <a:srgbClr val="16222D"/>
-                </a:solidFill>
-                <a:latin typeface="Segoe UI"/>
-              </a:rPr>
-              <a:t>Next:  </a:t>
-            </a:r>
-            <a:r>
-              <a:rPr sz="1100" b="0">
-                <a:solidFill>
-                  <a:srgbClr val="5C6B78"/>
-                </a:solidFill>
-                <a:latin typeface="Segoe UI"/>
-              </a:rPr>
-              <a:t>move the first supervisory state machine into Python.</a:t>
-            </a:r>
-          </a:p>
-        </p:txBody>
-      </p:sp>
+          <a:ln>
+            <a:tailEnd type="triangle"/>
+          </a:ln>
+        </p:spPr>
+        <p:style>
+          <a:lnRef idx="2">
+            <a:schemeClr val="accent1"/>
+          </a:lnRef>
+          <a:fillRef idx="0">
+            <a:schemeClr val="accent1"/>
+          </a:fillRef>
+          <a:effectRef idx="1">
+            <a:schemeClr val="accent1"/>
+          </a:effectRef>
+          <a:fontRef idx="minor">
+            <a:schemeClr val="tx1"/>
+          </a:fontRef>
+        </p:style>
+      </p:cxnSp>
+      <p:cxnSp>
+        <p:nvCxnSpPr>
+          <p:cNvPr id="34" name="Straight Arrow Connector 33">
+            <a:extLst>
+              <a:ext uri="{FF2B5EF4-FFF2-40B4-BE49-F238E27FC236}">
+                <a16:creationId xmlns:a16="http://schemas.microsoft.com/office/drawing/2014/main" id="{C7FD0F9A-26D9-826B-3755-BBBF1DC50FD0}"/>
+              </a:ext>
+            </a:extLst>
+          </p:cNvPr>
+          <p:cNvCxnSpPr>
+            <a:cxnSpLocks/>
+          </p:cNvCxnSpPr>
+          <p:nvPr/>
+        </p:nvCxnSpPr>
+        <p:spPr>
+          <a:xfrm flipH="1">
+            <a:off x="2659379" y="4746219"/>
+            <a:ext cx="960120" cy="0"/>
+          </a:xfrm>
+          <a:prstGeom prst="straightConnector1">
+            <a:avLst/>
+          </a:prstGeom>
+          <a:ln>
+            <a:tailEnd type="triangle"/>
+          </a:ln>
+        </p:spPr>
+        <p:style>
+          <a:lnRef idx="2">
+            <a:schemeClr val="accent1"/>
+          </a:lnRef>
+          <a:fillRef idx="0">
+            <a:schemeClr val="accent1"/>
+          </a:fillRef>
+          <a:effectRef idx="1">
+            <a:schemeClr val="accent1"/>
+          </a:effectRef>
+          <a:fontRef idx="minor">
+            <a:schemeClr val="tx1"/>
+          </a:fontRef>
+        </p:style>
+      </p:cxnSp>
     </p:spTree>
   </p:cSld>
   <p:clrMapOvr>

</xml_diff>